<commit_message>
Fase 3: tipografías de la marca incrustadas en el PPTX
PowerPoint reemplazaba Archivo, Figtree, IBM Plex Mono e Instrument Serif por
Calibri o Arial en computadores sin esas fuentes, y la presentación perdía el
estilo. Ahora el generador las incrusta (ppt/fonts/*.fntdata en EOT, lista
embeddedFontLst y embedTrueTypeFonts). Son OFL con fsType 0.

Co-Authored-By: Claude Opus 5.5 <noreply@anthropic.com>
Claude-Session: https://claude.ai/code/session_014Gx5fvuhNDZws2eZUNaczH
</commit_message>
<xml_diff>
--- a/fase-3/Grupo_01_LumineMotors_Fase3.pptx
+++ b/fase-3/Grupo_01_LumineMotors_Fase3.pptx
@@ -1,6 +1,6 @@
 
 <file path=ppt/presentation.xml><?xml version="1.0" encoding="utf-8"?>
-<p:presentation xmlns:a="http://schemas.openxmlformats.org/drawingml/2006/main" xmlns:r="http://schemas.openxmlformats.org/officeDocument/2006/relationships" xmlns:p="http://schemas.openxmlformats.org/presentationml/2006/main" saveSubsetFonts="1" autoCompressPictures="0">
+<p:presentation xmlns:a="http://schemas.openxmlformats.org/drawingml/2006/main" xmlns:r="http://schemas.openxmlformats.org/officeDocument/2006/relationships" xmlns:p="http://schemas.openxmlformats.org/presentationml/2006/main" embedTrueTypeFonts="1" saveSubsetFonts="1" autoCompressPictures="0">
   <p:sldMasterIdLst>
     <p:sldMasterId id="2147483648" r:id="rId1"/>
   </p:sldMasterIdLst>
@@ -46,6 +46,32 @@
   </p:notesMasterIdLst>
   <p:sldSz cx="12192000" cy="6858000"/>
   <p:notesSz cx="6858000" cy="12192000"/>
+  <p:embeddedFontLst>
+    <p:embeddedFont>
+      <p:font typeface="Archivo SemiExpanded ExtraBold" charset="0"/>
+      <p:regular r:id="rIdFuente1"/>
+    </p:embeddedFont>
+    <p:embeddedFont>
+      <p:font typeface="Archivo Condensed" charset="0"/>
+      <p:regular r:id="rIdFuente2"/>
+      <p:bold r:id="rIdFuente3"/>
+    </p:embeddedFont>
+    <p:embeddedFont>
+      <p:font typeface="Figtree" charset="0"/>
+      <p:regular r:id="rIdFuente4"/>
+      <p:bold r:id="rIdFuente5"/>
+    </p:embeddedFont>
+    <p:embeddedFont>
+      <p:font typeface="IBM Plex Mono" charset="0"/>
+      <p:regular r:id="rIdFuente6"/>
+      <p:bold r:id="rIdFuente7"/>
+    </p:embeddedFont>
+    <p:embeddedFont>
+      <p:font typeface="Instrument Serif" charset="0"/>
+      <p:regular r:id="rIdFuente8"/>
+      <p:italic r:id="rIdFuente9"/>
+    </p:embeddedFont>
+  </p:embeddedFontLst>
   <p:defaultTextStyle>
     <a:lvl1pPr marL="0" algn="l" defTabSz="914400" rtl="0" eaLnBrk="1" latinLnBrk="0" hangingPunct="1">
       <a:defRPr sz="1800" kern="1200">
@@ -141,7 +167,7 @@
   <p:extLst>
     <p:ext uri="{521415D9-36F7-43E2-AB2F-B90AF26B5E84}">
       <p14:sectionLst xmlns:p14="http://schemas.microsoft.com/office/powerpoint/2010/main">
-        <p14:section name="1 · Diego Alarcón" id="{31a57465-f046-a890-3fba-004c0b6f503e}">
+        <p14:section name="1 · Diego Alarcón" id="{089ce1e6-5804-5568-3269-ca0e7c696f18}">
           <p14:sldIdLst>
             <p14:sldId id="256"/>
             <p14:sldId id="257"/>
@@ -151,7 +177,7 @@
             <p14:sldId id="261"/>
           </p14:sldIdLst>
         </p14:section>
-        <p14:section name="2 · Benjamín Torres" id="{62978d07-2b1b-4e3c-509f-73954369e159}">
+        <p14:section name="2 · Benjamín Torres" id="{c01539df-1d22-eb7d-2b07-1064e95412b2}">
           <p14:sldIdLst>
             <p14:sldId id="262"/>
             <p14:sldId id="263"/>
@@ -162,7 +188,7 @@
             <p14:sldId id="268"/>
           </p14:sldIdLst>
         </p14:section>
-        <p14:section name="3 · Lukas Verdugo" id="{69348227-eaee-6823-e497-da742938b841}">
+        <p14:section name="3 · Lukas Verdugo" id="{e33f855c-95a2-0893-6d6c-9016cfb1eaf3}">
           <p14:sldIdLst>
             <p14:sldId id="269"/>
             <p14:sldId id="270"/>
@@ -176,7 +202,7 @@
             <p14:sldId id="278"/>
           </p14:sldIdLst>
         </p14:section>
-        <p14:section name="Anexo" id="{15ef1b95-106d-8ea4-09d5-52578879dc9b}">
+        <p14:section name="Anexo" id="{b68e2594-3674-0a59-f6f7-bfdccdfdc9a6}">
           <p14:sldIdLst>
             <p14:sldId id="279"/>
             <p14:sldId id="280"/>

</xml_diff>